<commit_message>
update a few slides
</commit_message>
<xml_diff>
--- a/Lectures/w1_day4_2026_data visualization.pptx
+++ b/Lectures/w1_day4_2026_data visualization.pptx
@@ -18997,8 +18997,8 @@
         </p:blipFill>
         <p:spPr>
           <a:xfrm>
-            <a:off x="680061" y="2907177"/>
-            <a:ext cx="2275351" cy="1703030"/>
+            <a:off x="680062" y="2907177"/>
+            <a:ext cx="1957548" cy="1419496"/>
           </a:xfrm>
           <a:prstGeom prst="rect">
             <a:avLst/>

</xml_diff>